<commit_message>
Last last version BePa2026
</commit_message>
<xml_diff>
--- a/2026_BePa_Winter_School/bepa2026_stats.pptx
+++ b/2026_BePa_Winter_School/bepa2026_stats.pptx
@@ -13970,10 +13970,10 @@
       </p:sp>
       <p:pic>
         <p:nvPicPr>
-          <p:cNvPr id="16" name="Image 15">
+          <p:cNvPr id="17" name="Image 16" descr="Une image contenant texte, capture d’écran, diagramme, ligne&#10;&#10;Le contenu généré par l’IA peut être incorrect.">
             <a:extLst>
               <a:ext uri="{FF2B5EF4-FFF2-40B4-BE49-F238E27FC236}">
-                <a16:creationId xmlns:a16="http://schemas.microsoft.com/office/drawing/2014/main" id="{9E8CBF7B-2D6F-7CBD-2982-72A0DE164A29}"/>
+                <a16:creationId xmlns:a16="http://schemas.microsoft.com/office/drawing/2014/main" id="{43A2C6A5-9FB2-2DEB-16B5-8C6BD425E0A5}"/>
               </a:ext>
             </a:extLst>
           </p:cNvPr>
@@ -13990,8 +13990,8 @@
         </p:blipFill>
         <p:spPr>
           <a:xfrm>
-            <a:off x="4572000" y="979586"/>
-            <a:ext cx="4101548" cy="3076161"/>
+            <a:off x="4721839" y="1045550"/>
+            <a:ext cx="3900847" cy="2925635"/>
           </a:xfrm>
           <a:prstGeom prst="rect">
             <a:avLst/>

</xml_diff>